<commit_message>
Demo: report/deck links use recorded files (fixes 404), fixed Monte Carlo, new dropdown UI
</commit_message>
<xml_diff>
--- a/demo/6a6f0be752/deck.pptx
+++ b/demo/6a6f0be752/deck.pptx
@@ -3776,7 +3776,7 @@
               </a:defRPr>
             </a:pPr>
             <a:r>
-              <a:t>•  8 claims challenged and re-researched; 1 court hearings</a:t>
+              <a:t>•  8 claims challenged and re-researched; 2 court hearings</a:t>
             </a:r>
           </a:p>
           <a:p>
@@ -4738,6 +4738,21 @@
             </a:pPr>
             <a:r>
               <a:t>•  QUALIFIED: Last year, Bengaluru-based Vogo raised USD 100 million from Ola to add 100,000 scooters t… — Exhibit c384 alone confirms the claim, but no independent evidence corroborates the $100 …</a:t>
+            </a:r>
+          </a:p>
+          <a:p>
+            <a:pPr>
+              <a:spcAft>
+                <a:spcPts val="800"/>
+              </a:spcAft>
+              <a:defRPr sz="1300">
+                <a:solidFill>
+                  <a:srgbClr val="6FD39A"/>
+                </a:solidFill>
+              </a:defRPr>
+            </a:pPr>
+            <a:r>
+              <a:t>•  AFFIRMED: Monthly rental plans start from ₹2,499/month. — Exhibit c213 explicitly states that monthly rental plans start from ₹2,499/month, and no …</a:t>
             </a:r>
           </a:p>
         </p:txBody>

</xml_diff>